<commit_message>
Add Sentry reading URL to week 7 materials
</commit_message>
<xml_diff>
--- a/cst4714_weeks1_7_review_with_script.pptx
+++ b/cst4714_weeks1_7_review_with_script.pptx
@@ -678,6 +678,12 @@
           <a:p>
             <a:r>
               <a:t>The Sentry reading matters because it shows why PostgreSQL maintenance is not just housekeeping. Transaction IDs are finite. If old rows are not cleaned up properly and the system approaches wraparound danger, PostgreSQL may stop accepting writes. It does that to protect correctness.</a:t>
+            </a:r>
+          </a:p>
+          <a:p/>
+          <a:p>
+            <a:r>
+              <a:t>The exact article URL for this activity is https://blog.sentry.io/transaction-id-wraparound-in-postgres/</a:t>
             </a:r>
           </a:p>
           <a:p/>
@@ -5533,6 +5539,22 @@
             </a:pPr>
             <a:r>
               <a:t>- Sentry traded some data in one noncritical table for faster recovery</a:t>
+            </a:r>
+          </a:p>
+          <a:p>
+            <a:pPr>
+              <a:spcAft>
+                <a:spcPts val="1000"/>
+              </a:spcAft>
+              <a:defRPr sz="2000">
+                <a:solidFill>
+                  <a:srgbClr val="F5F7FA"/>
+                </a:solidFill>
+                <a:latin typeface="Aptos"/>
+              </a:defRPr>
+            </a:pPr>
+            <a:r>
+              <a:t>- Reading URL: blog.sentry.io/transaction-id-wraparound-in-postgres/</a:t>
             </a:r>
           </a:p>
           <a:p>

</xml_diff>